<commit_message>
Rebuild public copies: PDF titles, icon alt text, session names in transcripts
</commit_message>
<xml_diff>
--- a/slides/01_Welcome_and_Overview.pptx
+++ b/slides/01_Welcome_and_Overview.pptx
@@ -20828,7 +20828,13 @@
       </p:sp>
       <p:pic>
         <p:nvPicPr>
-          <p:cNvPr id="6" name="plus" descr="plus"/>
+          <p:cNvPr id="6" name="plus">
+            <a:extLst>
+              <a:ext uri="{C183D7F6-B498-43B3-948B-1728B52AA6E4}">
+                <adec:decorative xmlns:adec="http://schemas.microsoft.com/office/drawing/2017/decorative" val="1"/>
+              </a:ext>
+            </a:extLst>
+          </p:cNvPr>
           <p:cNvPicPr>
             <a:picLocks noChangeAspect="1"/>
           </p:cNvPicPr>
@@ -20949,7 +20955,13 @@
       </p:sp>
       <p:pic>
         <p:nvPicPr>
-          <p:cNvPr id="10" name="equals" descr="equals"/>
+          <p:cNvPr id="10" name="equals">
+            <a:extLst>
+              <a:ext uri="{C183D7F6-B498-43B3-948B-1728B52AA6E4}">
+                <adec:decorative xmlns:adec="http://schemas.microsoft.com/office/drawing/2017/decorative" val="1"/>
+              </a:ext>
+            </a:extLst>
+          </p:cNvPr>
           <p:cNvPicPr>
             <a:picLocks noChangeAspect="1"/>
           </p:cNvPicPr>
@@ -21681,7 +21693,13 @@
       </p:pic>
       <p:pic>
         <p:nvPicPr>
-          <p:cNvPr id="4" name="Contact NaNDA" descr="Contact NaNDA, National Neighborhood Data Archive"/>
+          <p:cNvPr id="4" name="Contact NaNDA">
+            <a:extLst>
+              <a:ext uri="{C183D7F6-B498-43B3-948B-1728B52AA6E4}">
+                <adec:decorative xmlns:adec="http://schemas.microsoft.com/office/drawing/2017/decorative" val="1"/>
+              </a:ext>
+            </a:extLst>
+          </p:cNvPr>
           <p:cNvPicPr>
             <a:picLocks noChangeAspect="1"/>
           </p:cNvPicPr>

</xml_diff>